<commit_message>
feat: migrate outline WYSIWYG texts to Notion-style block arrays
</commit_message>
<xml_diff>
--- a/output/outline_evolution.pptx
+++ b/output/outline_evolution.pptx
@@ -3641,9 +3641,11 @@
               </a:rPr>
               <a:t>outline:
   draft_prompt: "..."
-  # [系统初版落笔留档] 
-  ★ original_draft: "当前振
-     幅 8.5, 存在风险。"
+  # [系统初版块列阵留档] 
+  ★ original_blocks:
+     - type: text
+       content: "当前振
+       幅8.5,存在风险。"
 # 👇 以下与第一阶段完全一致
 content:
   datasets:
@@ -3883,10 +3885,14 @@
                 <a:latin typeface="Consolas"/>
               </a:rPr>
               <a:t>outline:
-  original_draft: "..."
-  # [用户强烈意图标注]
-  ★ user_edited: "现场查看到
-     重度漏油，请增加三日折线。"
+  original_blocks: ...
+  # [Notion式混合区块]
+  ★ user_blocks:
+     - type: text
+       content: "看重度漏油"
+     ★- type: intent
+       command: chart
+       content: "加三日折线"
 content:
   datasets:
     # [1] 原生 sql (客观基石，不动)

</xml_diff>

<commit_message>
fix: adjust PPT shape Z-index to prevent highlight rectangles from covering text
</commit_message>
<xml_diff>
--- a/output/outline_evolution.pptx
+++ b/output/outline_evolution.pptx
@@ -3856,7 +3856,179 @@
       </p:sp>
       <p:sp>
         <p:nvSpPr>
-          <p:cNvPr id="21" name="TextBox 20"/>
+          <p:cNvPr id="21" name="Rectangle 20"/>
+          <p:cNvSpPr/>
+          <p:nvPr/>
+        </p:nvSpPr>
+        <p:spPr>
+          <a:xfrm>
+            <a:off x="8388000" y="1835999"/>
+            <a:ext cx="3312000" cy="432000"/>
+          </a:xfrm>
+          <a:prstGeom prst="rect">
+            <a:avLst/>
+          </a:prstGeom>
+          <a:solidFill>
+            <a:srgbClr val="FFE5E5"/>
+          </a:solidFill>
+          <a:ln>
+            <a:noFill/>
+          </a:ln>
+        </p:spPr>
+        <p:style>
+          <a:lnRef idx="1">
+            <a:schemeClr val="accent1"/>
+          </a:lnRef>
+          <a:fillRef idx="3">
+            <a:schemeClr val="accent1"/>
+          </a:fillRef>
+          <a:effectRef idx="2">
+            <a:schemeClr val="accent1"/>
+          </a:effectRef>
+          <a:fontRef idx="minor">
+            <a:schemeClr val="lt1"/>
+          </a:fontRef>
+        </p:style>
+        <p:txBody>
+          <a:bodyPr rtlCol="0" anchor="ctr"/>
+          <a:lstStyle/>
+          <a:p>
+            <a:pPr algn="ctr"/>
+          </a:p>
+        </p:txBody>
+      </p:sp>
+      <p:sp>
+        <p:nvSpPr>
+          <p:cNvPr id="22" name="Rectangle 21"/>
+          <p:cNvSpPr/>
+          <p:nvPr/>
+        </p:nvSpPr>
+        <p:spPr>
+          <a:xfrm>
+            <a:off x="8388000" y="3491999"/>
+            <a:ext cx="3312000" cy="216000"/>
+          </a:xfrm>
+          <a:prstGeom prst="rect">
+            <a:avLst/>
+          </a:prstGeom>
+          <a:solidFill>
+            <a:srgbClr val="FFE5E5"/>
+          </a:solidFill>
+          <a:ln>
+            <a:noFill/>
+          </a:ln>
+        </p:spPr>
+        <p:style>
+          <a:lnRef idx="1">
+            <a:schemeClr val="accent1"/>
+          </a:lnRef>
+          <a:fillRef idx="3">
+            <a:schemeClr val="accent1"/>
+          </a:fillRef>
+          <a:effectRef idx="2">
+            <a:schemeClr val="accent1"/>
+          </a:effectRef>
+          <a:fontRef idx="minor">
+            <a:schemeClr val="lt1"/>
+          </a:fontRef>
+        </p:style>
+        <p:txBody>
+          <a:bodyPr rtlCol="0" anchor="ctr"/>
+          <a:lstStyle/>
+          <a:p>
+            <a:pPr algn="ctr"/>
+          </a:p>
+        </p:txBody>
+      </p:sp>
+      <p:sp>
+        <p:nvSpPr>
+          <p:cNvPr id="23" name="Rectangle 22"/>
+          <p:cNvSpPr/>
+          <p:nvPr/>
+        </p:nvSpPr>
+        <p:spPr>
+          <a:xfrm>
+            <a:off x="8388000" y="4031999"/>
+            <a:ext cx="3312000" cy="432000"/>
+          </a:xfrm>
+          <a:prstGeom prst="rect">
+            <a:avLst/>
+          </a:prstGeom>
+          <a:solidFill>
+            <a:srgbClr val="FFE5E5"/>
+          </a:solidFill>
+          <a:ln>
+            <a:noFill/>
+          </a:ln>
+        </p:spPr>
+        <p:style>
+          <a:lnRef idx="1">
+            <a:schemeClr val="accent1"/>
+          </a:lnRef>
+          <a:fillRef idx="3">
+            <a:schemeClr val="accent1"/>
+          </a:fillRef>
+          <a:effectRef idx="2">
+            <a:schemeClr val="accent1"/>
+          </a:effectRef>
+          <a:fontRef idx="minor">
+            <a:schemeClr val="lt1"/>
+          </a:fontRef>
+        </p:style>
+        <p:txBody>
+          <a:bodyPr rtlCol="0" anchor="ctr"/>
+          <a:lstStyle/>
+          <a:p>
+            <a:pPr algn="ctr"/>
+          </a:p>
+        </p:txBody>
+      </p:sp>
+      <p:sp>
+        <p:nvSpPr>
+          <p:cNvPr id="24" name="Rectangle 23"/>
+          <p:cNvSpPr/>
+          <p:nvPr/>
+        </p:nvSpPr>
+        <p:spPr>
+          <a:xfrm>
+            <a:off x="8388000" y="5616000"/>
+            <a:ext cx="3312000" cy="576000"/>
+          </a:xfrm>
+          <a:prstGeom prst="rect">
+            <a:avLst/>
+          </a:prstGeom>
+          <a:solidFill>
+            <a:srgbClr val="FFE5E5"/>
+          </a:solidFill>
+          <a:ln>
+            <a:noFill/>
+          </a:ln>
+        </p:spPr>
+        <p:style>
+          <a:lnRef idx="1">
+            <a:schemeClr val="accent1"/>
+          </a:lnRef>
+          <a:fillRef idx="3">
+            <a:schemeClr val="accent1"/>
+          </a:fillRef>
+          <a:effectRef idx="2">
+            <a:schemeClr val="accent1"/>
+          </a:effectRef>
+          <a:fontRef idx="minor">
+            <a:schemeClr val="lt1"/>
+          </a:fontRef>
+        </p:style>
+        <p:txBody>
+          <a:bodyPr rtlCol="0" anchor="ctr"/>
+          <a:lstStyle/>
+          <a:p>
+            <a:pPr algn="ctr"/>
+          </a:p>
+        </p:txBody>
+      </p:sp>
+      <p:sp>
+        <p:nvSpPr>
+          <p:cNvPr id="25" name="TextBox 24"/>
           <p:cNvSpPr txBox="1"/>
           <p:nvPr/>
         </p:nvSpPr>
@@ -3912,178 +4084,6 @@
         layout: chart
         dataset_id: "ds_trend" </a:t>
             </a:r>
-          </a:p>
-        </p:txBody>
-      </p:sp>
-      <p:sp>
-        <p:nvSpPr>
-          <p:cNvPr id="22" name="Rectangle 21"/>
-          <p:cNvSpPr/>
-          <p:nvPr/>
-        </p:nvSpPr>
-        <p:spPr>
-          <a:xfrm>
-            <a:off x="8388000" y="1835999"/>
-            <a:ext cx="3312000" cy="432000"/>
-          </a:xfrm>
-          <a:prstGeom prst="rect">
-            <a:avLst/>
-          </a:prstGeom>
-          <a:solidFill>
-            <a:srgbClr val="FFE5E5"/>
-          </a:solidFill>
-          <a:ln>
-            <a:noFill/>
-          </a:ln>
-        </p:spPr>
-        <p:style>
-          <a:lnRef idx="1">
-            <a:schemeClr val="accent1"/>
-          </a:lnRef>
-          <a:fillRef idx="3">
-            <a:schemeClr val="accent1"/>
-          </a:fillRef>
-          <a:effectRef idx="2">
-            <a:schemeClr val="accent1"/>
-          </a:effectRef>
-          <a:fontRef idx="minor">
-            <a:schemeClr val="lt1"/>
-          </a:fontRef>
-        </p:style>
-        <p:txBody>
-          <a:bodyPr rtlCol="0" anchor="ctr"/>
-          <a:lstStyle/>
-          <a:p>
-            <a:pPr algn="ctr"/>
-          </a:p>
-        </p:txBody>
-      </p:sp>
-      <p:sp>
-        <p:nvSpPr>
-          <p:cNvPr id="23" name="Rectangle 22"/>
-          <p:cNvSpPr/>
-          <p:nvPr/>
-        </p:nvSpPr>
-        <p:spPr>
-          <a:xfrm>
-            <a:off x="8388000" y="3491999"/>
-            <a:ext cx="3312000" cy="216000"/>
-          </a:xfrm>
-          <a:prstGeom prst="rect">
-            <a:avLst/>
-          </a:prstGeom>
-          <a:solidFill>
-            <a:srgbClr val="FFE5E5"/>
-          </a:solidFill>
-          <a:ln>
-            <a:noFill/>
-          </a:ln>
-        </p:spPr>
-        <p:style>
-          <a:lnRef idx="1">
-            <a:schemeClr val="accent1"/>
-          </a:lnRef>
-          <a:fillRef idx="3">
-            <a:schemeClr val="accent1"/>
-          </a:fillRef>
-          <a:effectRef idx="2">
-            <a:schemeClr val="accent1"/>
-          </a:effectRef>
-          <a:fontRef idx="minor">
-            <a:schemeClr val="lt1"/>
-          </a:fontRef>
-        </p:style>
-        <p:txBody>
-          <a:bodyPr rtlCol="0" anchor="ctr"/>
-          <a:lstStyle/>
-          <a:p>
-            <a:pPr algn="ctr"/>
-          </a:p>
-        </p:txBody>
-      </p:sp>
-      <p:sp>
-        <p:nvSpPr>
-          <p:cNvPr id="24" name="Rectangle 23"/>
-          <p:cNvSpPr/>
-          <p:nvPr/>
-        </p:nvSpPr>
-        <p:spPr>
-          <a:xfrm>
-            <a:off x="8388000" y="4031999"/>
-            <a:ext cx="3312000" cy="432000"/>
-          </a:xfrm>
-          <a:prstGeom prst="rect">
-            <a:avLst/>
-          </a:prstGeom>
-          <a:solidFill>
-            <a:srgbClr val="FFE5E5"/>
-          </a:solidFill>
-          <a:ln>
-            <a:noFill/>
-          </a:ln>
-        </p:spPr>
-        <p:style>
-          <a:lnRef idx="1">
-            <a:schemeClr val="accent1"/>
-          </a:lnRef>
-          <a:fillRef idx="3">
-            <a:schemeClr val="accent1"/>
-          </a:fillRef>
-          <a:effectRef idx="2">
-            <a:schemeClr val="accent1"/>
-          </a:effectRef>
-          <a:fontRef idx="minor">
-            <a:schemeClr val="lt1"/>
-          </a:fontRef>
-        </p:style>
-        <p:txBody>
-          <a:bodyPr rtlCol="0" anchor="ctr"/>
-          <a:lstStyle/>
-          <a:p>
-            <a:pPr algn="ctr"/>
-          </a:p>
-        </p:txBody>
-      </p:sp>
-      <p:sp>
-        <p:nvSpPr>
-          <p:cNvPr id="25" name="Rectangle 24"/>
-          <p:cNvSpPr/>
-          <p:nvPr/>
-        </p:nvSpPr>
-        <p:spPr>
-          <a:xfrm>
-            <a:off x="8388000" y="5616000"/>
-            <a:ext cx="3312000" cy="576000"/>
-          </a:xfrm>
-          <a:prstGeom prst="rect">
-            <a:avLst/>
-          </a:prstGeom>
-          <a:solidFill>
-            <a:srgbClr val="FFE5E5"/>
-          </a:solidFill>
-          <a:ln>
-            <a:noFill/>
-          </a:ln>
-        </p:spPr>
-        <p:style>
-          <a:lnRef idx="1">
-            <a:schemeClr val="accent1"/>
-          </a:lnRef>
-          <a:fillRef idx="3">
-            <a:schemeClr val="accent1"/>
-          </a:fillRef>
-          <a:effectRef idx="2">
-            <a:schemeClr val="accent1"/>
-          </a:effectRef>
-          <a:fontRef idx="minor">
-            <a:schemeClr val="lt1"/>
-          </a:fontRef>
-        </p:style>
-        <p:txBody>
-          <a:bodyPr rtlCol="0" anchor="ctr"/>
-          <a:lstStyle/>
-          <a:p>
-            <a:pPr algn="ctr"/>
           </a:p>
         </p:txBody>
       </p:sp>

</xml_diff>

<commit_message>
fix: adjust all PPT shape Z-index and precise Y-coordinates for highlight blocks
</commit_message>
<xml_diff>
--- a/output/outline_evolution.pptx
+++ b/output/outline_evolution.pptx
@@ -3611,7 +3611,50 @@
       </p:sp>
       <p:sp>
         <p:nvSpPr>
-          <p:cNvPr id="15" name="TextBox 14"/>
+          <p:cNvPr id="15" name="Rectangle 14"/>
+          <p:cNvSpPr/>
+          <p:nvPr/>
+        </p:nvSpPr>
+        <p:spPr>
+          <a:xfrm>
+            <a:off x="4428000" y="1835999"/>
+            <a:ext cx="3312000" cy="720000"/>
+          </a:xfrm>
+          <a:prstGeom prst="rect">
+            <a:avLst/>
+          </a:prstGeom>
+          <a:solidFill>
+            <a:srgbClr val="FFE5E5"/>
+          </a:solidFill>
+          <a:ln>
+            <a:noFill/>
+          </a:ln>
+        </p:spPr>
+        <p:style>
+          <a:lnRef idx="1">
+            <a:schemeClr val="accent1"/>
+          </a:lnRef>
+          <a:fillRef idx="3">
+            <a:schemeClr val="accent1"/>
+          </a:fillRef>
+          <a:effectRef idx="2">
+            <a:schemeClr val="accent1"/>
+          </a:effectRef>
+          <a:fontRef idx="minor">
+            <a:schemeClr val="lt1"/>
+          </a:fontRef>
+        </p:style>
+        <p:txBody>
+          <a:bodyPr rtlCol="0" anchor="ctr"/>
+          <a:lstStyle/>
+          <a:p>
+            <a:pPr algn="ctr"/>
+          </a:p>
+        </p:txBody>
+      </p:sp>
+      <p:sp>
+        <p:nvSpPr>
+          <p:cNvPr id="16" name="TextBox 15"/>
           <p:cNvSpPr txBox="1"/>
           <p:nvPr/>
         </p:nvSpPr>
@@ -3665,20 +3708,90 @@
       </p:sp>
       <p:sp>
         <p:nvSpPr>
-          <p:cNvPr id="16" name="Rectangle 15"/>
+          <p:cNvPr id="17" name="TextBox 16"/>
+          <p:cNvSpPr txBox="1"/>
+          <p:nvPr/>
+        </p:nvSpPr>
+        <p:spPr>
+          <a:xfrm>
+            <a:off x="8280000" y="900000"/>
+            <a:ext cx="3528000" cy="180000"/>
+          </a:xfrm>
+          <a:prstGeom prst="rect">
+            <a:avLst/>
+          </a:prstGeom>
+          <a:noFill/>
+        </p:spPr>
+        <p:txBody>
+          <a:bodyPr wrap="square">
+            <a:spAutoFit/>
+          </a:bodyPr>
+          <a:lstStyle/>
+          <a:p>
+            <a:pPr algn="ctr"/>
+            <a:r>
+              <a:rPr sz="1400" b="1">
+                <a:solidFill>
+                  <a:srgbClr val="C7000F"/>
+                </a:solidFill>
+                <a:latin typeface="微软雅黑"/>
+              </a:rPr>
+              <a:t>阶段三：用户定稿态 (Agent 编译结果)</a:t>
+            </a:r>
+          </a:p>
+        </p:txBody>
+      </p:sp>
+      <p:sp>
+        <p:nvSpPr>
+          <p:cNvPr id="18" name="TextBox 17"/>
+          <p:cNvSpPr txBox="1"/>
+          <p:nvPr/>
+        </p:nvSpPr>
+        <p:spPr>
+          <a:xfrm>
+            <a:off x="8280000" y="1152000"/>
+            <a:ext cx="3528000" cy="288000"/>
+          </a:xfrm>
+          <a:prstGeom prst="rect">
+            <a:avLst/>
+          </a:prstGeom>
+          <a:noFill/>
+        </p:spPr>
+        <p:txBody>
+          <a:bodyPr wrap="square">
+            <a:spAutoFit/>
+          </a:bodyPr>
+          <a:lstStyle/>
+          <a:p>
+            <a:pPr algn="l"/>
+            <a:r>
+              <a:rPr sz="800" b="0">
+                <a:solidFill>
+                  <a:srgbClr val="2E2E2E"/>
+                </a:solidFill>
+                <a:latin typeface="微软雅黑"/>
+              </a:rPr>
+              <a:t>用户在界面修改后，Template Copilot 据此重构出来的被篡改且扩容终极 AST。</a:t>
+            </a:r>
+          </a:p>
+        </p:txBody>
+      </p:sp>
+      <p:sp>
+        <p:nvSpPr>
+          <p:cNvPr id="19" name="Rectangle 18"/>
           <p:cNvSpPr/>
           <p:nvPr/>
         </p:nvSpPr>
         <p:spPr>
           <a:xfrm>
-            <a:off x="4428000" y="1980000"/>
-            <a:ext cx="3312000" cy="432000"/>
+            <a:off x="8280000" y="1548000"/>
+            <a:ext cx="3528000" cy="5040000"/>
           </a:xfrm>
           <a:prstGeom prst="rect">
             <a:avLst/>
           </a:prstGeom>
           <a:solidFill>
-            <a:srgbClr val="FFE5E5"/>
+            <a:srgbClr val="F0F0F0"/>
           </a:solidFill>
           <a:ln>
             <a:noFill/>
@@ -3708,125 +3821,20 @@
       </p:sp>
       <p:sp>
         <p:nvSpPr>
-          <p:cNvPr id="17" name="TextBox 16"/>
-          <p:cNvSpPr txBox="1"/>
-          <p:nvPr/>
-        </p:nvSpPr>
-        <p:spPr>
-          <a:xfrm>
-            <a:off x="4464000" y="2015999"/>
-            <a:ext cx="3240000" cy="360000"/>
-          </a:xfrm>
-          <a:prstGeom prst="rect">
-            <a:avLst/>
-          </a:prstGeom>
-          <a:noFill/>
-        </p:spPr>
-        <p:txBody>
-          <a:bodyPr wrap="square">
-            <a:spAutoFit/>
-          </a:bodyPr>
-          <a:lstStyle/>
-          <a:p>
-            <a:pPr algn="l"/>
-            <a:r>
-              <a:rPr sz="750" b="1">
-                <a:solidFill>
-                  <a:srgbClr val="C7000F"/>
-                </a:solidFill>
-                <a:latin typeface="微软雅黑"/>
-              </a:rPr>
-              <a:t>★ 新增对原始事实的客观描述备份</a:t>
-            </a:r>
-          </a:p>
-        </p:txBody>
-      </p:sp>
-      <p:sp>
-        <p:nvSpPr>
-          <p:cNvPr id="18" name="TextBox 17"/>
-          <p:cNvSpPr txBox="1"/>
-          <p:nvPr/>
-        </p:nvSpPr>
-        <p:spPr>
-          <a:xfrm>
-            <a:off x="8280000" y="900000"/>
-            <a:ext cx="3528000" cy="180000"/>
-          </a:xfrm>
-          <a:prstGeom prst="rect">
-            <a:avLst/>
-          </a:prstGeom>
-          <a:noFill/>
-        </p:spPr>
-        <p:txBody>
-          <a:bodyPr wrap="square">
-            <a:spAutoFit/>
-          </a:bodyPr>
-          <a:lstStyle/>
-          <a:p>
-            <a:pPr algn="ctr"/>
-            <a:r>
-              <a:rPr sz="1400" b="1">
-                <a:solidFill>
-                  <a:srgbClr val="C7000F"/>
-                </a:solidFill>
-                <a:latin typeface="微软雅黑"/>
-              </a:rPr>
-              <a:t>阶段三：用户定稿态 (Agent 编译结果)</a:t>
-            </a:r>
-          </a:p>
-        </p:txBody>
-      </p:sp>
-      <p:sp>
-        <p:nvSpPr>
-          <p:cNvPr id="19" name="TextBox 18"/>
-          <p:cNvSpPr txBox="1"/>
-          <p:nvPr/>
-        </p:nvSpPr>
-        <p:spPr>
-          <a:xfrm>
-            <a:off x="8280000" y="1152000"/>
-            <a:ext cx="3528000" cy="288000"/>
-          </a:xfrm>
-          <a:prstGeom prst="rect">
-            <a:avLst/>
-          </a:prstGeom>
-          <a:noFill/>
-        </p:spPr>
-        <p:txBody>
-          <a:bodyPr wrap="square">
-            <a:spAutoFit/>
-          </a:bodyPr>
-          <a:lstStyle/>
-          <a:p>
-            <a:pPr algn="l"/>
-            <a:r>
-              <a:rPr sz="800" b="0">
-                <a:solidFill>
-                  <a:srgbClr val="2E2E2E"/>
-                </a:solidFill>
-                <a:latin typeface="微软雅黑"/>
-              </a:rPr>
-              <a:t>用户在界面修改后，Template Copilot 据此重构出来的被篡改且扩容终极 AST。</a:t>
-            </a:r>
-          </a:p>
-        </p:txBody>
-      </p:sp>
-      <p:sp>
-        <p:nvSpPr>
           <p:cNvPr id="20" name="Rectangle 19"/>
           <p:cNvSpPr/>
           <p:nvPr/>
         </p:nvSpPr>
         <p:spPr>
           <a:xfrm>
-            <a:off x="8280000" y="1548000"/>
-            <a:ext cx="3528000" cy="5040000"/>
+            <a:off x="8388000" y="1835999"/>
+            <a:ext cx="3312000" cy="1007999"/>
           </a:xfrm>
           <a:prstGeom prst="rect">
             <a:avLst/>
           </a:prstGeom>
           <a:solidFill>
-            <a:srgbClr val="F0F0F0"/>
+            <a:srgbClr val="FFE5E5"/>
           </a:solidFill>
           <a:ln>
             <a:noFill/>
@@ -3862,8 +3870,8 @@
         </p:nvSpPr>
         <p:spPr>
           <a:xfrm>
-            <a:off x="8388000" y="1835999"/>
-            <a:ext cx="3312000" cy="432000"/>
+            <a:off x="8388000" y="3816000"/>
+            <a:ext cx="3312000" cy="216000"/>
           </a:xfrm>
           <a:prstGeom prst="rect">
             <a:avLst/>
@@ -3905,8 +3913,8 @@
         </p:nvSpPr>
         <p:spPr>
           <a:xfrm>
-            <a:off x="8388000" y="3491999"/>
-            <a:ext cx="3312000" cy="216000"/>
+            <a:off x="8388000" y="4031999"/>
+            <a:ext cx="3312000" cy="432000"/>
           </a:xfrm>
           <a:prstGeom prst="rect">
             <a:avLst/>
@@ -3948,8 +3956,8 @@
         </p:nvSpPr>
         <p:spPr>
           <a:xfrm>
-            <a:off x="8388000" y="4031999"/>
-            <a:ext cx="3312000" cy="432000"/>
+            <a:off x="8388000" y="5220000"/>
+            <a:ext cx="3312000" cy="503999"/>
           </a:xfrm>
           <a:prstGeom prst="rect">
             <a:avLst/>
@@ -3985,50 +3993,7 @@
       </p:sp>
       <p:sp>
         <p:nvSpPr>
-          <p:cNvPr id="24" name="Rectangle 23"/>
-          <p:cNvSpPr/>
-          <p:nvPr/>
-        </p:nvSpPr>
-        <p:spPr>
-          <a:xfrm>
-            <a:off x="8388000" y="5616000"/>
-            <a:ext cx="3312000" cy="576000"/>
-          </a:xfrm>
-          <a:prstGeom prst="rect">
-            <a:avLst/>
-          </a:prstGeom>
-          <a:solidFill>
-            <a:srgbClr val="FFE5E5"/>
-          </a:solidFill>
-          <a:ln>
-            <a:noFill/>
-          </a:ln>
-        </p:spPr>
-        <p:style>
-          <a:lnRef idx="1">
-            <a:schemeClr val="accent1"/>
-          </a:lnRef>
-          <a:fillRef idx="3">
-            <a:schemeClr val="accent1"/>
-          </a:fillRef>
-          <a:effectRef idx="2">
-            <a:schemeClr val="accent1"/>
-          </a:effectRef>
-          <a:fontRef idx="minor">
-            <a:schemeClr val="lt1"/>
-          </a:fontRef>
-        </p:style>
-        <p:txBody>
-          <a:bodyPr rtlCol="0" anchor="ctr"/>
-          <a:lstStyle/>
-          <a:p>
-            <a:pPr algn="ctr"/>
-          </a:p>
-        </p:txBody>
-      </p:sp>
-      <p:sp>
-        <p:nvSpPr>
-          <p:cNvPr id="25" name="TextBox 24"/>
+          <p:cNvPr id="24" name="TextBox 23"/>
           <p:cNvSpPr txBox="1"/>
           <p:nvPr/>
         </p:nvSpPr>

</xml_diff>